<commit_message>
docs: QA1을 2지표(TTFT·throughput)로 재구성 — 각 baseline 대비 ≥2×
추론의 두 단계에 지표를 1:1 대응:
- TTFT(prefill 축): KV 재사용·retrieval(SSD-PIM) 가속 반영 — 평균 판정·p99 병행
- throughput(decode 축): tier 확장·압축 batch 확대 반영 — iso-latency(TPOT
  p99 ≤ baseline, vLLM SOSP'23 방법론) 판정·곡선 병행
- ★★★ = 두 지표 모두 ≥2×. v0.8의 임의 지연 가드(TPOT ≤ baseline 1.5×) 폐기,
  throughput 판정을 iso-latency로 강화

bin 근거를 지표별로 재배열:
- TTFT 2×: CacheBlend TTFT 2.2-3.3x↓(B, EuroSys'25) · SGLang prefix 재계산 제거
  · SmartANNS 검색 QPS ≤10.7×(B, SSD-PIM·ADR-001) → 하단 2.2× 보수 반올림
- throughput 2×: KIVI batch 4x로 2.35-3.47×(B) · vLLM paging 2-4×(B)
- AND로 묶음: 한쪽만 좋으면 한 단계만 최적화 — prefill·decode 결합이 MCR 가치

반영: QA 정의 v0.9 · 도출 v0.5 · 요구사항 분석 v0.9 · 덱 P7/P8/P9/부록 C-1

Co-Authored-By: Claude Fable 5 <noreply@anthropic.com>
Claude-Session: https://claude.ai/code/session_01Ac3Ujhu9jzcuyS8Z5KG22T
</commit_message>
<xml_diff>
--- a/docs/mcr_req_deck.pptx
+++ b/docs/mcr_req_deck.pptx
@@ -17006,7 +17006,7 @@
                           <a:ea typeface="Malgun Gothic" pitchFamily="34" charset="-122"/>
                           <a:cs typeface="Malgun Gothic" pitchFamily="34" charset="-120"/>
                         </a:rPr>
-                        <a:t> 「컨텍스트 폭증으로 KV cache가 HBM 용량을 넘는다 — 이 병목 해소가 효용성 입증의 핵심」 · </a:t>
+                        <a:t> 「컨텍스트 폭증으로 KV cache가 HBM 용량을 넘는다」 · </a:t>
                       </a:r>
                       <a:pPr algn="l" indent="0" marL="0">
                         <a:buNone/>
@@ -17158,7 +17158,7 @@
                           <a:ea typeface="Malgun Gothic" pitchFamily="34" charset="-122"/>
                           <a:cs typeface="Malgun Gothic" pitchFamily="34" charset="-120"/>
                         </a:rPr>
-                        <a:t>자체 실측: decode 대기 70–85%(A)</a:t>
+                        <a:t>prefill 축(TTFT)</a:t>
                       </a:r>
                       <a:pPr algn="l" indent="0" marL="0">
                         <a:buNone/>
@@ -17172,7 +17172,7 @@
                           <a:ea typeface="Malgun Gothic" pitchFamily="34" charset="-122"/>
                           <a:cs typeface="Malgun Gothic" pitchFamily="34" charset="-120"/>
                         </a:rPr>
-                        <a:t> — 메모리 개선이 곧 성능 개선 여지 · </a:t>
+                        <a:t>: KV 재사용·retrieval 가속 — CacheBlend TTFT 2.2–3.3×↓(B) · SmartANNS 검색 QPS ≤10.7×(B, SSD-PIM·ADR-001, </a:t>
                       </a:r>
                       <a:pPr algn="l" indent="0" marL="0">
                         <a:buNone/>
@@ -17186,7 +17186,7 @@
                           <a:ea typeface="Malgun Gothic" pitchFamily="34" charset="-122"/>
                           <a:cs typeface="Malgun Gothic" pitchFamily="34" charset="-120"/>
                         </a:rPr>
-                        <a:t>retrieval은 TTFT 임계 경로</a:t>
+                        <a:t>일반 런타임과의 차별 축</a:t>
                       </a:r>
                       <a:pPr algn="l" indent="0" marL="0">
                         <a:buNone/>
@@ -17200,7 +17200,7 @@
                           <a:ea typeface="Malgun Gothic" pitchFamily="34" charset="-122"/>
                           <a:cs typeface="Malgun Gothic" pitchFamily="34" charset="-120"/>
                         </a:rPr>
-                        <a:t> — SSD ANN은 I/O가 ~67%(B, SmartANNS) → SSD-PIM 근접 검색 가속이 E2E 성능에 직접 기여(ADR-001) — </a:t>
+                        <a:t>) // </a:t>
                       </a:r>
                       <a:pPr algn="l" indent="0" marL="0">
                         <a:buNone/>
@@ -17214,7 +17214,21 @@
                           <a:ea typeface="Malgun Gothic" pitchFamily="34" charset="-122"/>
                           <a:cs typeface="Malgun Gothic" pitchFamily="34" charset="-120"/>
                         </a:rPr>
-                        <a:t>KV 관리만 하는 일반 런타임과의 차별 축</a:t>
+                        <a:t>decode 축(throughput)</a:t>
+                      </a:r>
+                      <a:pPr algn="l" indent="0" marL="0">
+                        <a:buNone/>
+                      </a:pPr>
+                      <a:r>
+                        <a:rPr lang="en-US" sz="800" dirty="0">
+                          <a:solidFill>
+                            <a:srgbClr val="262626"/>
+                          </a:solidFill>
+                          <a:latin typeface="Malgun Gothic" pitchFamily="34" charset="0"/>
+                          <a:ea typeface="Malgun Gothic" pitchFamily="34" charset="-122"/>
+                          <a:cs typeface="Malgun Gothic" pitchFamily="34" charset="-120"/>
+                        </a:rPr>
+                        <a:t>: tier 확장·압축 batch — KIVI 2.35–3.47×·vLLM 2–4×(B), decode 대기 70–85%(A)</a:t>
                       </a:r>
                       <a:endParaRPr lang="en-US" sz="800" dirty="0">
                         <a:latin typeface="Malgun Gothic" charset="0"/>
@@ -17306,7 +17320,7 @@
                           <a:ea typeface="Malgun Gothic" pitchFamily="34" charset="-122"/>
                           <a:cs typeface="Malgun Gothic" pitchFamily="34" charset="-120"/>
                         </a:rPr>
-                        <a:t>baseline 대비 throughput ≥2× (지연 가드 내) — 최종 판정 지표</a:t>
+                        <a:t>baseline 대비 TTFT·throughput 모두 ≥2× — 최종 판정 지표</a:t>
                       </a:r>
                       <a:endParaRPr lang="en-US" sz="800" dirty="0">
                         <a:latin typeface="Malgun Gothic" charset="0"/>
@@ -20470,7 +20484,7 @@
                           <a:ea typeface="Malgun Gothic" pitchFamily="34" charset="-122"/>
                           <a:cs typeface="Malgun Gothic" pitchFamily="34" charset="-120"/>
                         </a:rPr>
-                        <a:t>지연 가드 내 최대 처리율 (baseline 대비 throughput)</a:t>
+                        <a:t>prefill·decode 2단 성능 (baseline 대비 TTFT · throughput)</a:t>
                       </a:r>
                       <a:endParaRPr lang="en-US" sz="800" dirty="0">
                         <a:latin typeface="Malgun Gothic" charset="0"/>
@@ -20538,7 +20552,7 @@
                           <a:ea typeface="Malgun Gothic" pitchFamily="34" charset="-122"/>
                           <a:cs typeface="Malgun Gothic" pitchFamily="34" charset="-120"/>
                         </a:rPr>
-                        <a:t>대표 워크로드를 동일 HW·동일 실행 구성에서 서빙 — </a:t>
+                        <a:t>retrieval(SSD-PIM 가속) 포함 E2E — </a:t>
                       </a:r>
                       <a:pPr algn="l" indent="0" marL="0">
                         <a:buNone/>
@@ -20552,7 +20566,7 @@
                           <a:ea typeface="Malgun Gothic" pitchFamily="34" charset="-122"/>
                           <a:cs typeface="Malgun Gothic" pitchFamily="34" charset="-120"/>
                         </a:rPr>
-                        <a:t>retrieval(SSD-PIM 근접 가속) 포함 E2E 경로</a:t>
+                        <a:t>TTFT(prefill: 재사용·검색)</a:t>
                       </a:r>
                       <a:pPr algn="l" indent="0" marL="0">
                         <a:buNone/>
@@ -20566,7 +20580,35 @@
                           <a:ea typeface="Malgun Gothic" pitchFamily="34" charset="-122"/>
                           <a:cs typeface="Malgun Gothic" pitchFamily="34" charset="-120"/>
                         </a:rPr>
-                        <a:t>의 처리율</a:t>
+                        <a:t> · </a:t>
+                      </a:r>
+                      <a:pPr algn="l" indent="0" marL="0">
+                        <a:buNone/>
+                      </a:pPr>
+                      <a:r>
+                        <a:rPr lang="en-US" sz="800" b="1" dirty="0">
+                          <a:solidFill>
+                            <a:srgbClr val="1F3864"/>
+                          </a:solidFill>
+                          <a:latin typeface="Malgun Gothic" pitchFamily="34" charset="0"/>
+                          <a:ea typeface="Malgun Gothic" pitchFamily="34" charset="-122"/>
+                          <a:cs typeface="Malgun Gothic" pitchFamily="34" charset="-120"/>
+                        </a:rPr>
+                        <a:t>throughput(decode: tier·압축)</a:t>
+                      </a:r>
+                      <a:pPr algn="l" indent="0" marL="0">
+                        <a:buNone/>
+                      </a:pPr>
+                      <a:r>
+                        <a:rPr lang="en-US" sz="800" dirty="0">
+                          <a:solidFill>
+                            <a:srgbClr val="262626"/>
+                          </a:solidFill>
+                          <a:latin typeface="Malgun Gothic" pitchFamily="34" charset="0"/>
+                          <a:ea typeface="Malgun Gothic" pitchFamily="34" charset="-122"/>
+                          <a:cs typeface="Malgun Gothic" pitchFamily="34" charset="-120"/>
+                        </a:rPr>
+                        <a:t> 2지표</a:t>
                       </a:r>
                       <a:pPr algn="l" indent="0" marL="0">
                         <a:buNone/>
@@ -20590,7 +20632,7 @@
                           <a:ea typeface="Malgun Gothic" pitchFamily="34" charset="-122"/>
                           <a:cs typeface="Malgun Gothic" pitchFamily="34" charset="-120"/>
                         </a:rPr>
-                        <a:t>[측정: baseline 대비 throughput 배율 — 지연 가드(TPOT p99 ≤ baseline 1.5×) 내 측정 · 곡선 병행 보고 — baseline = GPU HBM 단일 tier(순증분 분리)]</a:t>
+                        <a:t>[측정: TTFT·throughput 모두 ≥2× → ★★★ · throughput은 iso-latency(TPOT p99 ≤ baseline) 판정·곡선 병행 — baseline = GPU HBM 단일 tier(순증분 분리)]</a:t>
                       </a:r>
                       <a:endParaRPr lang="en-US" sz="800" dirty="0">
                         <a:latin typeface="Malgun Gothic" charset="0"/>
@@ -27529,7 +27571,7 @@
                           <a:ea typeface="Malgun Gothic" pitchFamily="34" charset="-122"/>
                           <a:cs typeface="Malgun Gothic" pitchFamily="34" charset="-120"/>
                         </a:rPr>
-                        <a:t>지연 가드 내 최대 처리율 — retrieval(SSD-PIM 가속) 포함 E2E 경로</a:t>
+                        <a:t>prefill·decode 2단 성능 — retrieval(SSD-PIM 가속) 포함 E2E: TTFT(prefill) · throughput(decode)</a:t>
                       </a:r>
                       <a:endParaRPr lang="en-US" sz="900" dirty="0">
                         <a:latin typeface="Malgun Gothic" charset="0"/>
@@ -27597,7 +27639,7 @@
                           <a:ea typeface="Malgun Gothic" pitchFamily="34" charset="-122"/>
                           <a:cs typeface="Malgun Gothic" pitchFamily="34" charset="-120"/>
                         </a:rPr>
-                        <a:t>baseline 대비 throughput 배율 — 지연 가드 TPOT p99 ≤ baseline 1.5× · 곡선 병행 보고 — baseline = 동일 HW의 GPU HBM 단일 tier</a:t>
+                        <a:t>① TTFT 단축 배율 — 평균 판정·p99 병행 · ② throughput 배율 — iso-latency(TPOT p99 ≤ baseline)·곡선 병행 — baseline = GPU HBM 단일 tier</a:t>
                       </a:r>
                       <a:endParaRPr lang="en-US" sz="900" dirty="0">
                         <a:latin typeface="Malgun Gothic" charset="0"/>
@@ -27665,7 +27707,7 @@
                           <a:ea typeface="Malgun Gothic" pitchFamily="34" charset="-122"/>
                           <a:cs typeface="Malgun Gothic" pitchFamily="34" charset="-120"/>
                         </a:rPr>
-                        <a:t>≥ 2×  (★★☆ 1.5–2× 단독 기법 수준 · ★☆☆ &lt; 1.5× 또는 가드 위반)</a:t>
+                        <a:t>TTFT·throughput 모두 ≥ 2×  (★★☆ 둘 다 ≥1.5×·한쪽 2× 미달 · ★☆☆ 한쪽 &lt;1.5×)</a:t>
                       </a:r>
                       <a:endParaRPr lang="en-US" sz="900" dirty="0">
                         <a:latin typeface="Malgun Gothic" charset="0"/>
@@ -39632,7 +39674,7 @@
                 <a:ea typeface="Malgun Gothic" pitchFamily="34" charset="-122"/>
                 <a:cs typeface="Malgun Gothic" pitchFamily="34" charset="-120"/>
               </a:rPr>
-              <a:t>부록 C-1. QA1 추론 성능 (throughput)</a:t>
+              <a:t>부록 C-1. QA1 추론 성능 (TTFT · throughput)</a:t>
             </a:r>
             <a:endParaRPr lang="en-US" sz="2400" dirty="0"/>
           </a:p>
@@ -40293,7 +40335,7 @@
                 <a:ea typeface="Malgun Gothic" pitchFamily="34" charset="-122"/>
                 <a:cs typeface="Malgun Gothic" pitchFamily="34" charset="-120"/>
               </a:rPr>
-              <a:t>정의: </a:t>
+              <a:t>정의 — 왜 2지표: </a:t>
             </a:r>
             <a:pPr algn="l" indent="0" marL="0">
               <a:spcAft>
@@ -40310,7 +40352,7 @@
                 <a:ea typeface="Malgun Gothic" pitchFamily="34" charset="-122"/>
                 <a:cs typeface="Malgun Gothic" pitchFamily="34" charset="-120"/>
               </a:rPr>
-              <a:t>지연 가드 안에서 달성하는 최대 처리율(throughput)의 </a:t>
+              <a:t>추론은 </a:t>
             </a:r>
             <a:pPr algn="l" indent="0" marL="0">
               <a:spcAft>
@@ -40327,7 +40369,7 @@
                 <a:ea typeface="Malgun Gothic" pitchFamily="34" charset="-122"/>
                 <a:cs typeface="Malgun Gothic" pitchFamily="34" charset="-120"/>
               </a:rPr>
-              <a:t>baseline 대비 배율</a:t>
+              <a:t>prefill(첫 토큰까지) · decode(생성 지속)</a:t>
             </a:r>
             <a:pPr algn="l" indent="0" marL="0">
               <a:spcAft>
@@ -40344,41 +40386,7 @@
                 <a:ea typeface="Malgun Gothic" pitchFamily="34" charset="-122"/>
                 <a:cs typeface="Malgun Gothic" pitchFamily="34" charset="-120"/>
               </a:rPr>
-              <a:t> — retrieval(유사도 검색, SSD-PIM 가속 — ADR-001)을 </a:t>
-            </a:r>
-            <a:pPr algn="l" indent="0" marL="0">
-              <a:spcAft>
-                <a:spcPts val="600"/>
-              </a:spcAft>
-              <a:buNone/>
-            </a:pPr>
-            <a:r>
-              <a:rPr lang="en-US" sz="1000" b="1" dirty="0">
-                <a:solidFill>
-                  <a:srgbClr val="1F3864"/>
-                </a:solidFill>
-                <a:latin typeface="Malgun Gothic" pitchFamily="34" charset="0"/>
-                <a:ea typeface="Malgun Gothic" pitchFamily="34" charset="-122"/>
-                <a:cs typeface="Malgun Gothic" pitchFamily="34" charset="-120"/>
-              </a:rPr>
-              <a:t>포함한 E2E 경로</a:t>
-            </a:r>
-            <a:pPr algn="l" indent="0" marL="0">
-              <a:spcAft>
-                <a:spcPts val="600"/>
-              </a:spcAft>
-              <a:buNone/>
-            </a:pPr>
-            <a:r>
-              <a:rPr lang="en-US" sz="1000" dirty="0">
-                <a:solidFill>
-                  <a:srgbClr val="262626"/>
-                </a:solidFill>
-                <a:latin typeface="Malgun Gothic" pitchFamily="34" charset="0"/>
-                <a:ea typeface="Malgun Gothic" pitchFamily="34" charset="-122"/>
-                <a:cs typeface="Malgun Gothic" pitchFamily="34" charset="-120"/>
-              </a:rPr>
-              <a:t>로 측정</a:t>
+              <a:t> 2단계로 나뉘고 MCR 최적화가 각 단계에 1:1 대응 — 합성 지표로 뭉치면 어느 단계 개선인지 흐려지므로 분리 측정</a:t>
             </a:r>
             <a:endParaRPr lang="en-US" sz="1000" dirty="0"/>
           </a:p>
@@ -40399,7 +40407,7 @@
                 <a:ea typeface="Malgun Gothic" pitchFamily="34" charset="-122"/>
                 <a:cs typeface="Malgun Gothic" pitchFamily="34" charset="-120"/>
               </a:rPr>
-              <a:t>측정: </a:t>
+              <a:t>① TTFT (prefill 축): </a:t>
             </a:r>
             <a:pPr algn="l" indent="0" marL="0">
               <a:spcAft>
@@ -40416,7 +40424,7 @@
                 <a:ea typeface="Malgun Gothic" pitchFamily="34" charset="-122"/>
                 <a:cs typeface="Malgun Gothic" pitchFamily="34" charset="-120"/>
               </a:rPr>
-              <a:t>부하 스윕으로 throughput–latency 곡선을 얻고, </a:t>
+              <a:t>KV 재사용·retrieval 가속이 줄이는 첫 토큰 지연 — baseline 대비 단축 배율. </a:t>
             </a:r>
             <a:pPr algn="l" indent="0" marL="0">
               <a:spcAft>
@@ -40433,7 +40441,7 @@
                 <a:ea typeface="Malgun Gothic" pitchFamily="34" charset="-122"/>
                 <a:cs typeface="Malgun Gothic" pitchFamily="34" charset="-120"/>
               </a:rPr>
-              <a:t>지연 가드(TPOT p99 ≤ baseline의 1.5×)</a:t>
+              <a:t>평균 기준 판정 · p99 병행</a:t>
             </a:r>
             <a:pPr algn="l" indent="0" marL="0">
               <a:spcAft>
@@ -40450,7 +40458,45 @@
                 <a:ea typeface="Malgun Gothic" pitchFamily="34" charset="-122"/>
                 <a:cs typeface="Malgun Gothic" pitchFamily="34" charset="-120"/>
               </a:rPr>
-              <a:t> 내 최대 처리율을 비교 — </a:t>
+              <a:t> (재사용 hit/miss 이질성 — 꼬리는 cold 요청 지배)</a:t>
+            </a:r>
+            <a:endParaRPr lang="en-US" sz="1000" dirty="0"/>
+          </a:p>
+          <a:p>
+            <a:pPr algn="l" marL="177800" indent="-177800">
+              <a:spcAft>
+                <a:spcPts val="600"/>
+              </a:spcAft>
+              <a:buSzPct val="100000"/>
+              <a:buChar char="◆"/>
+            </a:pPr>
+            <a:r>
+              <a:rPr lang="en-US" sz="1000" b="1" dirty="0">
+                <a:solidFill>
+                  <a:srgbClr val="1F3864"/>
+                </a:solidFill>
+                <a:latin typeface="Malgun Gothic" pitchFamily="34" charset="0"/>
+                <a:ea typeface="Malgun Gothic" pitchFamily="34" charset="-122"/>
+                <a:cs typeface="Malgun Gothic" pitchFamily="34" charset="-120"/>
+              </a:rPr>
+              <a:t>② throughput (decode 축): </a:t>
+            </a:r>
+            <a:pPr algn="l" indent="0" marL="0">
+              <a:spcAft>
+                <a:spcPts val="600"/>
+              </a:spcAft>
+              <a:buNone/>
+            </a:pPr>
+            <a:r>
+              <a:rPr lang="en-US" sz="1000" dirty="0">
+                <a:solidFill>
+                  <a:srgbClr val="262626"/>
+                </a:solidFill>
+                <a:latin typeface="Malgun Gothic" pitchFamily="34" charset="0"/>
+                <a:ea typeface="Malgun Gothic" pitchFamily="34" charset="-122"/>
+                <a:cs typeface="Malgun Gothic" pitchFamily="34" charset="-120"/>
+              </a:rPr>
+              <a:t>tier 확장·압축의 batch 확대로 오르는 생성 처리량 — baseline 대비 배율. </a:t>
             </a:r>
             <a:pPr algn="l" indent="0" marL="0">
               <a:spcAft>
@@ -40467,7 +40513,7 @@
                 <a:ea typeface="Malgun Gothic" pitchFamily="34" charset="-122"/>
                 <a:cs typeface="Malgun Gothic" pitchFamily="34" charset="-120"/>
               </a:rPr>
-              <a:t>판정은 가드 내 배율, 보고는 곡선 병행</a:t>
+              <a:t>iso-latency(TPOT p99 ≤ baseline) 판정 · 곡선 병행</a:t>
             </a:r>
             <a:pPr algn="l" indent="0" marL="0">
               <a:spcAft>
@@ -40484,7 +40530,7 @@
                 <a:ea typeface="Malgun Gothic" pitchFamily="34" charset="-122"/>
                 <a:cs typeface="Malgun Gothic" pitchFamily="34" charset="-120"/>
               </a:rPr>
-              <a:t> (체리피킹 방지)</a:t>
+              <a:t> (지연 팔아 산 처리량 배제, vLLM SOSP'23 방법론)</a:t>
             </a:r>
             <a:endParaRPr lang="en-US" sz="1000" dirty="0"/>
           </a:p>
@@ -40556,62 +40602,7 @@
                 <a:ea typeface="Malgun Gothic" pitchFamily="34" charset="-122"/>
                 <a:cs typeface="Malgun Gothic" pitchFamily="34" charset="-120"/>
               </a:rPr>
-              <a:t> — 타겟 메모리 없이 달성 가능한 최선이므로 도입의 순증분이 분리 측정됨. P/D 분리는 실험 변수(양쪽 동일 적용)</a:t>
-            </a:r>
-            <a:endParaRPr lang="en-US" sz="1000" dirty="0"/>
-          </a:p>
-          <a:p>
-            <a:pPr algn="l" marL="177800" indent="-177800">
-              <a:spcAft>
-                <a:spcPts val="600"/>
-              </a:spcAft>
-              <a:buSzPct val="100000"/>
-              <a:buChar char="◆"/>
-            </a:pPr>
-            <a:r>
-              <a:rPr lang="en-US" sz="1000" b="1" dirty="0">
-                <a:solidFill>
-                  <a:srgbClr val="1F3864"/>
-                </a:solidFill>
-                <a:latin typeface="Malgun Gothic" pitchFamily="34" charset="0"/>
-                <a:ea typeface="Malgun Gothic" pitchFamily="34" charset="-122"/>
-                <a:cs typeface="Malgun Gothic" pitchFamily="34" charset="-120"/>
-              </a:rPr>
-              <a:t>왜 goodput@SLO가 아닌가: </a:t>
-            </a:r>
-            <a:pPr algn="l" indent="0" marL="0">
-              <a:spcAft>
-                <a:spcPts val="600"/>
-              </a:spcAft>
-              <a:buNone/>
-            </a:pPr>
-            <a:r>
-              <a:rPr lang="en-US" sz="1000" dirty="0">
-                <a:solidFill>
-                  <a:srgbClr val="262626"/>
-                </a:solidFill>
-                <a:latin typeface="Malgun Gothic" pitchFamily="34" charset="0"/>
-                <a:ea typeface="Malgun Gothic" pitchFamily="34" charset="-122"/>
-                <a:cs typeface="Malgun Gothic" pitchFamily="34" charset="-120"/>
-              </a:rPr>
-              <a:t>절대 SLO(450ms/200ms)는 GPU 종류·규모 비확정인 연구 테스트베드에서 취약(미달 시 goodput=0으로 지표 퇴화) — 배율 지표가 문헌과 직접 비교됨. </a:t>
-            </a:r>
-            <a:pPr algn="l" indent="0" marL="0">
-              <a:spcAft>
-                <a:spcPts val="600"/>
-              </a:spcAft>
-              <a:buNone/>
-            </a:pPr>
-            <a:r>
-              <a:rPr lang="en-US" sz="1000" b="1" dirty="0">
-                <a:solidFill>
-                  <a:srgbClr val="1F3864"/>
-                </a:solidFill>
-                <a:latin typeface="Malgun Gothic" pitchFamily="34" charset="0"/>
-                <a:ea typeface="Malgun Gothic" pitchFamily="34" charset="-122"/>
-                <a:cs typeface="Malgun Gothic" pitchFamily="34" charset="-120"/>
-              </a:rPr>
-              <a:t>상용화 단계에 goodput@SLO로 승격</a:t>
+              <a:t> — 순증분 분리 측정. P/D 분리는 실험 변수(양쪽 동일 적용). goodput@SLO는 상용화 단계 승격(절대 SLO는 연구 테스트베드서 취약)</a:t>
             </a:r>
             <a:endParaRPr lang="en-US" sz="1000" dirty="0"/>
           </a:p>
@@ -40926,7 +40917,7 @@
                           <a:ea typeface="Malgun Gothic" pitchFamily="34" charset="-122"/>
                           <a:cs typeface="Malgun Gothic" pitchFamily="34" charset="-120"/>
                         </a:rPr>
-                        <a:t>baseline 대비 throughput ≥ 2× — 결합(압축×재사용×tiering×근접연산)의 부가가치 입증선</a:t>
+                        <a:t>TTFT ≥ 2× 그리고 throughput ≥ 2× (둘 다 충족)</a:t>
                       </a:r>
                       <a:endParaRPr lang="en-US" sz="900" dirty="0">
                         <a:latin typeface="Malgun Gothic" charset="0"/>
@@ -41064,7 +41055,7 @@
                           <a:ea typeface="Malgun Gothic" pitchFamily="34" charset="-122"/>
                           <a:cs typeface="Malgun Gothic" pitchFamily="34" charset="-120"/>
                         </a:rPr>
-                        <a:t>1.5× – 2× — 단독 기법(압축만 등)으로도 도달 가능한 수준</a:t>
+                        <a:t>두 지표 모두 ≥ 1.5×, 한쪽이라도 2× 미달</a:t>
                       </a:r>
                       <a:endParaRPr lang="en-US" sz="900" dirty="0">
                         <a:latin typeface="Malgun Gothic" charset="0"/>
@@ -41202,7 +41193,7 @@
                           <a:ea typeface="Malgun Gothic" pitchFamily="34" charset="-122"/>
                           <a:cs typeface="Malgun Gothic" pitchFamily="34" charset="-120"/>
                         </a:rPr>
-                        <a:t>&lt; 1.5×, 또는 지연 가드 위반 구성으로만 달성</a:t>
+                        <a:t>어느 한 지표라도 &lt; 1.5×</a:t>
                       </a:r>
                       <a:endParaRPr lang="en-US" sz="900" dirty="0">
                         <a:latin typeface="Malgun Gothic" charset="0"/>
@@ -41266,7 +41257,7 @@
         </p:nvSpPr>
         <p:spPr>
           <a:xfrm>
-            <a:off x="6537960" y="3648456"/>
+            <a:off x="6537960" y="3355848"/>
             <a:ext cx="5333695" cy="310896"/>
           </a:xfrm>
           <a:prstGeom prst="rect">
@@ -41286,7 +41277,7 @@
         </p:nvSpPr>
         <p:spPr>
           <a:xfrm>
-            <a:off x="6583680" y="3648456"/>
+            <a:off x="6583680" y="3355848"/>
             <a:ext cx="5242255" cy="310896"/>
           </a:xfrm>
           <a:prstGeom prst="rect">
@@ -41325,8 +41316,8 @@
         </p:nvSpPr>
         <p:spPr>
           <a:xfrm>
-            <a:off x="6583680" y="4050792"/>
-            <a:ext cx="5242255" cy="2377440"/>
+            <a:off x="6583680" y="3758184"/>
+            <a:ext cx="5242255" cy="2670048"/>
           </a:xfrm>
           <a:prstGeom prst="rect">
             <a:avLst/>
@@ -41346,6 +41337,23 @@
               <a:buChar char="◆"/>
             </a:pPr>
             <a:r>
+              <a:rPr lang="en-US" sz="900" b="1" dirty="0">
+                <a:solidFill>
+                  <a:srgbClr val="1F3864"/>
+                </a:solidFill>
+                <a:latin typeface="Malgun Gothic" pitchFamily="34" charset="0"/>
+                <a:ea typeface="Malgun Gothic" pitchFamily="34" charset="-122"/>
+                <a:cs typeface="Malgun Gothic" pitchFamily="34" charset="-120"/>
+              </a:rPr>
+              <a:t>① TTFT 2× (prefill): </a:t>
+            </a:r>
+            <a:pPr algn="l" indent="0" marL="0">
+              <a:spcAft>
+                <a:spcPts val="600"/>
+              </a:spcAft>
+              <a:buNone/>
+            </a:pPr>
+            <a:r>
               <a:rPr lang="en-US" sz="900" dirty="0">
                 <a:solidFill>
                   <a:srgbClr val="262626"/>
@@ -41354,7 +41362,7 @@
                 <a:ea typeface="Malgun Gothic" pitchFamily="34" charset="-122"/>
                 <a:cs typeface="Malgun Gothic" pitchFamily="34" charset="-120"/>
               </a:rPr>
-              <a:t>2× = 축별 단독 실측이 모두 2× 초과: 압축 </a:t>
+              <a:t>CacheBlend RAG 재사용 </a:t>
             </a:r>
             <a:pPr algn="l" indent="0" marL="0">
               <a:spcAft>
@@ -41371,7 +41379,7 @@
                 <a:ea typeface="Malgun Gothic" pitchFamily="34" charset="-122"/>
                 <a:cs typeface="Malgun Gothic" pitchFamily="34" charset="-120"/>
               </a:rPr>
-              <a:t>KIVI 2.35–3.47×(B)</a:t>
+              <a:t>TTFT 2.2–3.3×↓(B, EuroSys'25 Best Paper)</a:t>
             </a:r>
             <a:pPr algn="l" indent="0" marL="0">
               <a:spcAft>
@@ -41388,7 +41396,7 @@
                 <a:ea typeface="Malgun Gothic" pitchFamily="34" charset="-122"/>
                 <a:cs typeface="Malgun Gothic" pitchFamily="34" charset="-120"/>
               </a:rPr>
-              <a:t> · RAG KV 재사용 </a:t>
+              <a:t> · SGLang prefix 재계산 제거(B) · 검색 SmartANNS </a:t>
             </a:r>
             <a:pPr algn="l" indent="0" marL="0">
               <a:spcAft>
@@ -41405,7 +41413,7 @@
                 <a:ea typeface="Malgun Gothic" pitchFamily="34" charset="-122"/>
                 <a:cs typeface="Malgun Gothic" pitchFamily="34" charset="-120"/>
               </a:rPr>
-              <a:t>CacheBlend 2.8–5×(B, EuroSys'25 Best Paper)</a:t>
+              <a:t>QPS ≤10.7×(B, SSD-PIM·ADR-001)</a:t>
             </a:r>
             <a:pPr algn="l" indent="0" marL="0">
               <a:spcAft>
@@ -41422,7 +41430,45 @@
                 <a:ea typeface="Malgun Gothic" pitchFamily="34" charset="-122"/>
                 <a:cs typeface="Malgun Gothic" pitchFamily="34" charset="-120"/>
               </a:rPr>
-              <a:t> · prefix 재사용 </a:t>
+              <a:t> → 2×는 CacheBlend 하단 2.2×의 보수 반올림(C)</a:t>
+            </a:r>
+            <a:endParaRPr lang="en-US" sz="900" dirty="0"/>
+          </a:p>
+          <a:p>
+            <a:pPr algn="l" marL="177800" indent="-177800">
+              <a:spcAft>
+                <a:spcPts val="600"/>
+              </a:spcAft>
+              <a:buSzPct val="100000"/>
+              <a:buChar char="◆"/>
+            </a:pPr>
+            <a:r>
+              <a:rPr lang="en-US" sz="900" b="1" dirty="0">
+                <a:solidFill>
+                  <a:srgbClr val="1F3864"/>
+                </a:solidFill>
+                <a:latin typeface="Malgun Gothic" pitchFamily="34" charset="0"/>
+                <a:ea typeface="Malgun Gothic" pitchFamily="34" charset="-122"/>
+                <a:cs typeface="Malgun Gothic" pitchFamily="34" charset="-120"/>
+              </a:rPr>
+              <a:t>② throughput 2× (decode): </a:t>
+            </a:r>
+            <a:pPr algn="l" indent="0" marL="0">
+              <a:spcAft>
+                <a:spcPts val="600"/>
+              </a:spcAft>
+              <a:buNone/>
+            </a:pPr>
+            <a:r>
+              <a:rPr lang="en-US" sz="900" dirty="0">
+                <a:solidFill>
+                  <a:srgbClr val="262626"/>
+                </a:solidFill>
+                <a:latin typeface="Malgun Gothic" pitchFamily="34" charset="0"/>
+                <a:ea typeface="Malgun Gothic" pitchFamily="34" charset="-122"/>
+                <a:cs typeface="Malgun Gothic" pitchFamily="34" charset="-120"/>
+              </a:rPr>
+              <a:t>KIVI batch 4×로 </a:t>
             </a:r>
             <a:pPr algn="l" indent="0" marL="0">
               <a:spcAft>
@@ -41439,7 +41485,7 @@
                 <a:ea typeface="Malgun Gothic" pitchFamily="34" charset="-122"/>
                 <a:cs typeface="Malgun Gothic" pitchFamily="34" charset="-120"/>
               </a:rPr>
-              <a:t>SGLang ≤6.4×(B)</a:t>
+              <a:t>처리율 2.35–3.47×(B)</a:t>
             </a:r>
             <a:pPr algn="l" indent="0" marL="0">
               <a:spcAft>
@@ -41456,7 +41502,7 @@
                 <a:ea typeface="Malgun Gothic" pitchFamily="34" charset="-122"/>
                 <a:cs typeface="Malgun Gothic" pitchFamily="34" charset="-120"/>
               </a:rPr>
-              <a:t> · paging </a:t>
+              <a:t> · vLLM paging </a:t>
             </a:r>
             <a:pPr algn="l" indent="0" marL="0">
               <a:spcAft>
@@ -41473,7 +41519,7 @@
                 <a:ea typeface="Malgun Gothic" pitchFamily="34" charset="-122"/>
                 <a:cs typeface="Malgun Gothic" pitchFamily="34" charset="-120"/>
               </a:rPr>
-              <a:t>vLLM 2–4×(B)</a:t>
+              <a:t>2–4×(B)</a:t>
             </a:r>
             <a:pPr algn="l" indent="0" marL="0">
               <a:spcAft>
@@ -41490,13 +41536,17 @@
                 <a:ea typeface="Malgun Gothic" pitchFamily="34" charset="-122"/>
                 <a:cs typeface="Malgun Gothic" pitchFamily="34" charset="-120"/>
               </a:rPr>
-              <a:t> · 검색 </a:t>
+              <a:t> → tier 확장이 batch를 더 키우므로 단독 하단 2× 요구(C)</a:t>
             </a:r>
-            <a:pPr algn="l" indent="0" marL="0">
+            <a:endParaRPr lang="en-US" sz="900" dirty="0"/>
+          </a:p>
+          <a:p>
+            <a:pPr algn="l" marL="177800" indent="-177800">
               <a:spcAft>
                 <a:spcPts val="600"/>
               </a:spcAft>
-              <a:buNone/>
+              <a:buSzPct val="100000"/>
+              <a:buChar char="◆"/>
             </a:pPr>
             <a:r>
               <a:rPr lang="en-US" sz="900" b="1" dirty="0">
@@ -41507,7 +41557,7 @@
                 <a:ea typeface="Malgun Gothic" pitchFamily="34" charset="-122"/>
                 <a:cs typeface="Malgun Gothic" pitchFamily="34" charset="-120"/>
               </a:rPr>
-              <a:t>SmartANNS QPS ≤10.7×(B)</a:t>
+              <a:t>AND로 묶는 이유: </a:t>
             </a:r>
             <a:pPr algn="l" indent="0" marL="0">
               <a:spcAft>
@@ -41524,49 +41574,7 @@
                 <a:ea typeface="Malgun Gothic" pitchFamily="34" charset="-122"/>
                 <a:cs typeface="Malgun Gothic" pitchFamily="34" charset="-120"/>
               </a:rPr>
-              <a:t> → 결합 시스템에 단독 축 하단(2×) 요구는 보수적(C)</a:t>
-            </a:r>
-            <a:endParaRPr lang="en-US" sz="900" dirty="0"/>
-          </a:p>
-          <a:p>
-            <a:pPr algn="l" marL="177800" indent="-177800">
-              <a:spcAft>
-                <a:spcPts val="600"/>
-              </a:spcAft>
-              <a:buSzPct val="100000"/>
-              <a:buChar char="◆"/>
-            </a:pPr>
-            <a:r>
-              <a:rPr lang="en-US" sz="900" dirty="0">
-                <a:solidFill>
-                  <a:srgbClr val="262626"/>
-                </a:solidFill>
-                <a:latin typeface="Malgun Gothic" pitchFamily="34" charset="0"/>
-                <a:ea typeface="Malgun Gothic" pitchFamily="34" charset="-122"/>
-                <a:cs typeface="Malgun Gothic" pitchFamily="34" charset="-120"/>
-              </a:rPr>
-              <a:t>1.5×는 압축 단독(KIVI)의 보수 하한 — 결합 부가가치 입증선이 못 되므로 ★★☆로 강등(C)</a:t>
-            </a:r>
-            <a:endParaRPr lang="en-US" sz="900" dirty="0"/>
-          </a:p>
-          <a:p>
-            <a:pPr algn="l" marL="177800" indent="-177800">
-              <a:spcAft>
-                <a:spcPts val="600"/>
-              </a:spcAft>
-              <a:buSzPct val="100000"/>
-              <a:buChar char="◆"/>
-            </a:pPr>
-            <a:r>
-              <a:rPr lang="en-US" sz="900" dirty="0">
-                <a:solidFill>
-                  <a:srgbClr val="262626"/>
-                </a:solidFill>
-                <a:latin typeface="Malgun Gothic" pitchFamily="34" charset="0"/>
-                <a:ea typeface="Malgun Gothic" pitchFamily="34" charset="-122"/>
-                <a:cs typeface="Malgun Gothic" pitchFamily="34" charset="-120"/>
-              </a:rPr>
-              <a:t>지연 가드 1.5× = FlexGen형(지연 수십 초 offline 처리량 100×) 퇴화 구성 배제(C) — 컷라인 임의성은 곡선 병행 보고로 보완</a:t>
+              <a:t>한쪽만 좋으면 한 단계만 최적화한 것 — MCR 가치는 prefill·decode 결합이므로 둘 다 2× 요구(C). 구 지연 가드 1.5×(임의 배수)는 폐기, iso-latency로 대체(v0.9)</a:t>
             </a:r>
             <a:endParaRPr lang="en-US" sz="900" dirty="0"/>
           </a:p>

</xml_diff>